<commit_message>
docs(ppt+defense): slide12 next-steps + KB row -> full-import-in-progress era
Co-Authored-By: Claude Code <noreply@anthropic.com>
</commit_message>
<xml_diff>
--- a/deck/ict-deck.pptx
+++ b/deck/ict-deck.pptx
@@ -6678,7 +6678,7 @@
                 <a:ea typeface="微软雅黑"/>
                 <a:cs typeface="微软雅黑"/>
               </a:rPr>
-              <a:t>知识库全量导入按 batch 200 实测约 15.8 小时（1,864,451 块），但要占满写入窗口，故采用 15,494 块分层子集策略</a:t>
+              <a:t>知识库全量导入 10-27 发车、断点续跑吃批中（10-29 已入 60 万+/75.7 万块），满库后一键复跑刷新全部评测快照</a:t>
             </a:r>
           </a:p>
         </p:txBody>
@@ -6744,7 +6744,7 @@
                 <a:ea typeface="微软雅黑"/>
                 <a:cs typeface="微软雅黑"/>
               </a:rPr>
-              <a:t>下一步：知识库定全量筛选策略（15,494 块子集已入库）→ 人工确认闸门入库 → 第二行业真实语料迁移。</a:t>
+              <a:t>下一步：满库复跑刷新评测快照（replay 一键）→ 人工确认闸门入库 → 第二行业真实语料迁移。</a:t>
             </a:r>
           </a:p>
         </p:txBody>

</xml_diff>